<commit_message>
feat(presentation): redesign 8-slide presentation deck into clean modern light theme
</commit_message>
<xml_diff>
--- a/public/Vyapar_2.0_Official_Presentation.pptx
+++ b/public/Vyapar_2.0_Official_Presentation.pptx
@@ -3110,7 +3110,7 @@
             <a:avLst/>
           </a:prstGeom>
           <a:solidFill>
-            <a:srgbClr val="0A0F1D"/>
+            <a:srgbClr val="F8FAFC"/>
           </a:solidFill>
           <a:ln>
             <a:noFill/>
@@ -3163,7 +3163,7 @@
             <a:pPr>
               <a:defRPr sz="1100" b="1">
                 <a:solidFill>
-                  <a:srgbClr val="6366F1"/>
+                  <a:srgbClr val="4F46E5"/>
                 </a:solidFill>
                 <a:latin typeface="Arial"/>
               </a:defRPr>
@@ -3179,7 +3179,7 @@
               </a:spcBef>
               <a:defRPr sz="4400" b="1">
                 <a:solidFill>
-                  <a:srgbClr val="FFFFFF"/>
+                  <a:srgbClr val="0F172A"/>
                 </a:solidFill>
                 <a:latin typeface="Arial"/>
               </a:defRPr>
@@ -3195,7 +3195,7 @@
               </a:spcBef>
               <a:defRPr sz="1500">
                 <a:solidFill>
-                  <a:srgbClr val="CBD5E1"/>
+                  <a:srgbClr val="475569"/>
                 </a:solidFill>
                 <a:latin typeface="Arial"/>
               </a:defRPr>
@@ -3211,7 +3211,7 @@
               </a:spcBef>
               <a:defRPr sz="1100" b="1">
                 <a:solidFill>
-                  <a:srgbClr val="06B6D4"/>
+                  <a:srgbClr val="4F46E5"/>
                 </a:solidFill>
                 <a:latin typeface="Arial"/>
               </a:defRPr>
@@ -3237,11 +3237,11 @@
             <a:avLst/>
           </a:prstGeom>
           <a:solidFill>
-            <a:srgbClr val="131B2E"/>
+            <a:srgbClr val="FFFFFF"/>
           </a:solidFill>
           <a:ln w="19050">
             <a:solidFill>
-              <a:srgbClr val="6366F1"/>
+              <a:srgbClr val="4F46E5"/>
             </a:solidFill>
           </a:ln>
         </p:spPr>
@@ -3266,7 +3266,7 @@
             <a:pPr algn="ctr">
               <a:defRPr sz="1100" b="1">
                 <a:solidFill>
-                  <a:srgbClr val="6366F1"/>
+                  <a:srgbClr val="4F46E5"/>
                 </a:solidFill>
                 <a:latin typeface="Arial"/>
               </a:defRPr>
@@ -3282,7 +3282,7 @@
               </a:spcBef>
               <a:defRPr sz="1300" b="1">
                 <a:solidFill>
-                  <a:srgbClr val="FFFFFF"/>
+                  <a:srgbClr val="0F172A"/>
                 </a:solidFill>
                 <a:latin typeface="Arial"/>
               </a:defRPr>
@@ -3298,7 +3298,7 @@
               </a:spcBef>
               <a:defRPr sz="1300" b="1">
                 <a:solidFill>
-                  <a:srgbClr val="FFFFFF"/>
+                  <a:srgbClr val="0F172A"/>
                 </a:solidFill>
                 <a:latin typeface="Arial"/>
               </a:defRPr>
@@ -3314,7 +3314,7 @@
               </a:spcBef>
               <a:defRPr sz="1300" b="1">
                 <a:solidFill>
-                  <a:srgbClr val="FFFFFF"/>
+                  <a:srgbClr val="0F172A"/>
                 </a:solidFill>
                 <a:latin typeface="Arial"/>
               </a:defRPr>
@@ -3330,7 +3330,7 @@
               </a:spcBef>
               <a:defRPr sz="1300" b="1">
                 <a:solidFill>
-                  <a:srgbClr val="FFFFFF"/>
+                  <a:srgbClr val="0F172A"/>
                 </a:solidFill>
                 <a:latin typeface="Arial"/>
               </a:defRPr>
@@ -3398,7 +3398,7 @@
             <a:avLst/>
           </a:prstGeom>
           <a:solidFill>
-            <a:srgbClr val="0A0F1D"/>
+            <a:srgbClr val="F8FAFC"/>
           </a:solidFill>
           <a:ln>
             <a:noFill/>
@@ -3451,7 +3451,7 @@
             <a:pPr>
               <a:defRPr sz="1100" b="1">
                 <a:solidFill>
-                  <a:srgbClr val="EF4444"/>
+                  <a:srgbClr val="DC2626"/>
                 </a:solidFill>
                 <a:latin typeface="Arial"/>
               </a:defRPr>
@@ -3487,7 +3487,7 @@
             <a:pPr>
               <a:defRPr sz="2600" b="1">
                 <a:solidFill>
-                  <a:srgbClr val="FFFFFF"/>
+                  <a:srgbClr val="0F172A"/>
                 </a:solidFill>
                 <a:latin typeface="Arial"/>
               </a:defRPr>
@@ -3523,7 +3523,7 @@
             <a:pPr>
               <a:defRPr sz="1200">
                 <a:solidFill>
-                  <a:srgbClr val="94A3B8"/>
+                  <a:srgbClr val="64748B"/>
                 </a:solidFill>
                 <a:latin typeface="Arial"/>
               </a:defRPr>
@@ -3549,11 +3549,11 @@
             <a:avLst/>
           </a:prstGeom>
           <a:solidFill>
-            <a:srgbClr val="131B2E"/>
+            <a:srgbClr val="FFFFFF"/>
           </a:solidFill>
           <a:ln w="19050">
             <a:solidFill>
-              <a:srgbClr val="EF4444"/>
+              <a:srgbClr val="DC2626"/>
             </a:solidFill>
           </a:ln>
         </p:spPr>
@@ -3578,7 +3578,7 @@
             <a:pPr algn="ctr">
               <a:defRPr sz="1300" b="1">
                 <a:solidFill>
-                  <a:srgbClr val="FFFFFF"/>
+                  <a:srgbClr val="0F172A"/>
                 </a:solidFill>
                 <a:latin typeface="Arial"/>
               </a:defRPr>
@@ -3594,7 +3594,7 @@
               </a:spcBef>
               <a:defRPr sz="1050">
                 <a:solidFill>
-                  <a:srgbClr val="CBD5E1"/>
+                  <a:srgbClr val="475569"/>
                 </a:solidFill>
                 <a:latin typeface="Arial"/>
               </a:defRPr>
@@ -3620,11 +3620,11 @@
             <a:avLst/>
           </a:prstGeom>
           <a:solidFill>
-            <a:srgbClr val="131B2E"/>
+            <a:srgbClr val="FFFFFF"/>
           </a:solidFill>
           <a:ln w="19050">
             <a:solidFill>
-              <a:srgbClr val="EF4444"/>
+              <a:srgbClr val="DC2626"/>
             </a:solidFill>
           </a:ln>
         </p:spPr>
@@ -3649,7 +3649,7 @@
             <a:pPr algn="ctr">
               <a:defRPr sz="1300" b="1">
                 <a:solidFill>
-                  <a:srgbClr val="FFFFFF"/>
+                  <a:srgbClr val="0F172A"/>
                 </a:solidFill>
                 <a:latin typeface="Arial"/>
               </a:defRPr>
@@ -3665,7 +3665,7 @@
               </a:spcBef>
               <a:defRPr sz="1050">
                 <a:solidFill>
-                  <a:srgbClr val="CBD5E1"/>
+                  <a:srgbClr val="475569"/>
                 </a:solidFill>
                 <a:latin typeface="Arial"/>
               </a:defRPr>
@@ -3691,11 +3691,11 @@
             <a:avLst/>
           </a:prstGeom>
           <a:solidFill>
-            <a:srgbClr val="131B2E"/>
+            <a:srgbClr val="FFFFFF"/>
           </a:solidFill>
           <a:ln w="19050">
             <a:solidFill>
-              <a:srgbClr val="EF4444"/>
+              <a:srgbClr val="DC2626"/>
             </a:solidFill>
           </a:ln>
         </p:spPr>
@@ -3720,7 +3720,7 @@
             <a:pPr algn="ctr">
               <a:defRPr sz="1300" b="1">
                 <a:solidFill>
-                  <a:srgbClr val="FFFFFF"/>
+                  <a:srgbClr val="0F172A"/>
                 </a:solidFill>
                 <a:latin typeface="Arial"/>
               </a:defRPr>
@@ -3736,7 +3736,7 @@
               </a:spcBef>
               <a:defRPr sz="1050">
                 <a:solidFill>
-                  <a:srgbClr val="CBD5E1"/>
+                  <a:srgbClr val="475569"/>
                 </a:solidFill>
                 <a:latin typeface="Arial"/>
               </a:defRPr>
@@ -3762,11 +3762,11 @@
             <a:avLst/>
           </a:prstGeom>
           <a:solidFill>
-            <a:srgbClr val="131B2E"/>
+            <a:srgbClr val="FFFFFF"/>
           </a:solidFill>
           <a:ln w="19050">
             <a:solidFill>
-              <a:srgbClr val="EF4444"/>
+              <a:srgbClr val="DC2626"/>
             </a:solidFill>
           </a:ln>
         </p:spPr>
@@ -3791,7 +3791,7 @@
             <a:pPr algn="ctr">
               <a:defRPr sz="1300" b="1">
                 <a:solidFill>
-                  <a:srgbClr val="FFFFFF"/>
+                  <a:srgbClr val="0F172A"/>
                 </a:solidFill>
                 <a:latin typeface="Arial"/>
               </a:defRPr>
@@ -3807,7 +3807,7 @@
               </a:spcBef>
               <a:defRPr sz="1050">
                 <a:solidFill>
-                  <a:srgbClr val="CBD5E1"/>
+                  <a:srgbClr val="475569"/>
                 </a:solidFill>
                 <a:latin typeface="Arial"/>
               </a:defRPr>
@@ -3875,7 +3875,7 @@
             <a:avLst/>
           </a:prstGeom>
           <a:solidFill>
-            <a:srgbClr val="0A0F1D"/>
+            <a:srgbClr val="F8FAFC"/>
           </a:solidFill>
           <a:ln>
             <a:noFill/>
@@ -3928,7 +3928,7 @@
             <a:pPr>
               <a:defRPr sz="1100" b="1">
                 <a:solidFill>
-                  <a:srgbClr val="10B981"/>
+                  <a:srgbClr val="059669"/>
                 </a:solidFill>
                 <a:latin typeface="Arial"/>
               </a:defRPr>
@@ -3964,7 +3964,7 @@
             <a:pPr>
               <a:defRPr sz="2600" b="1">
                 <a:solidFill>
-                  <a:srgbClr val="FFFFFF"/>
+                  <a:srgbClr val="0F172A"/>
                 </a:solidFill>
                 <a:latin typeface="Arial"/>
               </a:defRPr>
@@ -4000,7 +4000,7 @@
             <a:pPr>
               <a:defRPr sz="1200">
                 <a:solidFill>
-                  <a:srgbClr val="94A3B8"/>
+                  <a:srgbClr val="64748B"/>
                 </a:solidFill>
                 <a:latin typeface="Arial"/>
               </a:defRPr>
@@ -4026,11 +4026,11 @@
             <a:avLst/>
           </a:prstGeom>
           <a:solidFill>
-            <a:srgbClr val="131B2E"/>
+            <a:srgbClr val="FFFFFF"/>
           </a:solidFill>
           <a:ln w="19050">
             <a:solidFill>
-              <a:srgbClr val="6366F1"/>
+              <a:srgbClr val="4F46E5"/>
             </a:solidFill>
           </a:ln>
         </p:spPr>
@@ -4055,7 +4055,7 @@
             <a:pPr algn="ctr">
               <a:defRPr sz="1300" b="1">
                 <a:solidFill>
-                  <a:srgbClr val="FFFFFF"/>
+                  <a:srgbClr val="0F172A"/>
                 </a:solidFill>
                 <a:latin typeface="Arial"/>
               </a:defRPr>
@@ -4071,7 +4071,7 @@
               </a:spcBef>
               <a:defRPr sz="1050">
                 <a:solidFill>
-                  <a:srgbClr val="CBD5E1"/>
+                  <a:srgbClr val="475569"/>
                 </a:solidFill>
                 <a:latin typeface="Arial"/>
               </a:defRPr>
@@ -4097,11 +4097,11 @@
             <a:avLst/>
           </a:prstGeom>
           <a:solidFill>
-            <a:srgbClr val="131B2E"/>
+            <a:srgbClr val="FFFFFF"/>
           </a:solidFill>
           <a:ln w="19050">
             <a:solidFill>
-              <a:srgbClr val="10B981"/>
+              <a:srgbClr val="059669"/>
             </a:solidFill>
           </a:ln>
         </p:spPr>
@@ -4126,7 +4126,7 @@
             <a:pPr algn="ctr">
               <a:defRPr sz="1300" b="1">
                 <a:solidFill>
-                  <a:srgbClr val="FFFFFF"/>
+                  <a:srgbClr val="0F172A"/>
                 </a:solidFill>
                 <a:latin typeface="Arial"/>
               </a:defRPr>
@@ -4142,7 +4142,7 @@
               </a:spcBef>
               <a:defRPr sz="1050">
                 <a:solidFill>
-                  <a:srgbClr val="CBD5E1"/>
+                  <a:srgbClr val="475569"/>
                 </a:solidFill>
                 <a:latin typeface="Arial"/>
               </a:defRPr>
@@ -4168,11 +4168,11 @@
             <a:avLst/>
           </a:prstGeom>
           <a:solidFill>
-            <a:srgbClr val="131B2E"/>
+            <a:srgbClr val="FFFFFF"/>
           </a:solidFill>
           <a:ln w="19050">
             <a:solidFill>
-              <a:srgbClr val="06B6D4"/>
+              <a:srgbClr val="0284C7"/>
             </a:solidFill>
           </a:ln>
         </p:spPr>
@@ -4197,7 +4197,7 @@
             <a:pPr algn="ctr">
               <a:defRPr sz="1300" b="1">
                 <a:solidFill>
-                  <a:srgbClr val="FFFFFF"/>
+                  <a:srgbClr val="0F172A"/>
                 </a:solidFill>
                 <a:latin typeface="Arial"/>
               </a:defRPr>
@@ -4213,7 +4213,7 @@
               </a:spcBef>
               <a:defRPr sz="1050">
                 <a:solidFill>
-                  <a:srgbClr val="CBD5E1"/>
+                  <a:srgbClr val="475569"/>
                 </a:solidFill>
                 <a:latin typeface="Arial"/>
               </a:defRPr>
@@ -4239,11 +4239,11 @@
             <a:avLst/>
           </a:prstGeom>
           <a:solidFill>
-            <a:srgbClr val="131B2E"/>
+            <a:srgbClr val="FFFFFF"/>
           </a:solidFill>
           <a:ln w="19050">
             <a:solidFill>
-              <a:srgbClr val="8B5CF6"/>
+              <a:srgbClr val="7C3AED"/>
             </a:solidFill>
           </a:ln>
         </p:spPr>
@@ -4268,7 +4268,7 @@
             <a:pPr algn="ctr">
               <a:defRPr sz="1300" b="1">
                 <a:solidFill>
-                  <a:srgbClr val="FFFFFF"/>
+                  <a:srgbClr val="0F172A"/>
                 </a:solidFill>
                 <a:latin typeface="Arial"/>
               </a:defRPr>
@@ -4284,7 +4284,7 @@
               </a:spcBef>
               <a:defRPr sz="1050">
                 <a:solidFill>
-                  <a:srgbClr val="CBD5E1"/>
+                  <a:srgbClr val="475569"/>
                 </a:solidFill>
                 <a:latin typeface="Arial"/>
               </a:defRPr>
@@ -4352,7 +4352,7 @@
             <a:avLst/>
           </a:prstGeom>
           <a:solidFill>
-            <a:srgbClr val="0A0F1D"/>
+            <a:srgbClr val="F8FAFC"/>
           </a:solidFill>
           <a:ln>
             <a:noFill/>
@@ -4405,7 +4405,7 @@
             <a:pPr>
               <a:defRPr sz="1100" b="1">
                 <a:solidFill>
-                  <a:srgbClr val="06B6D4"/>
+                  <a:srgbClr val="0284C7"/>
                 </a:solidFill>
                 <a:latin typeface="Arial"/>
               </a:defRPr>
@@ -4441,7 +4441,7 @@
             <a:pPr>
               <a:defRPr sz="2600" b="1">
                 <a:solidFill>
-                  <a:srgbClr val="FFFFFF"/>
+                  <a:srgbClr val="0F172A"/>
                 </a:solidFill>
                 <a:latin typeface="Arial"/>
               </a:defRPr>
@@ -4477,7 +4477,7 @@
             <a:pPr>
               <a:defRPr sz="1200">
                 <a:solidFill>
-                  <a:srgbClr val="94A3B8"/>
+                  <a:srgbClr val="64748B"/>
                 </a:solidFill>
                 <a:latin typeface="Arial"/>
               </a:defRPr>
@@ -4503,11 +4503,11 @@
             <a:avLst/>
           </a:prstGeom>
           <a:solidFill>
-            <a:srgbClr val="131B2E"/>
+            <a:srgbClr val="FFFFFF"/>
           </a:solidFill>
           <a:ln w="19050">
             <a:solidFill>
-              <a:srgbClr val="6366F1"/>
+              <a:srgbClr val="4F46E5"/>
             </a:solidFill>
           </a:ln>
         </p:spPr>
@@ -4532,7 +4532,7 @@
             <a:pPr algn="ctr">
               <a:defRPr sz="1300" b="1">
                 <a:solidFill>
-                  <a:srgbClr val="FFFFFF"/>
+                  <a:srgbClr val="0F172A"/>
                 </a:solidFill>
                 <a:latin typeface="Arial"/>
               </a:defRPr>
@@ -4548,7 +4548,7 @@
               </a:spcBef>
               <a:defRPr sz="1050">
                 <a:solidFill>
-                  <a:srgbClr val="CBD5E1"/>
+                  <a:srgbClr val="475569"/>
                 </a:solidFill>
                 <a:latin typeface="Arial"/>
               </a:defRPr>
@@ -4574,11 +4574,11 @@
             <a:avLst/>
           </a:prstGeom>
           <a:solidFill>
-            <a:srgbClr val="131B2E"/>
+            <a:srgbClr val="FFFFFF"/>
           </a:solidFill>
           <a:ln w="19050">
             <a:solidFill>
-              <a:srgbClr val="10B981"/>
+              <a:srgbClr val="059669"/>
             </a:solidFill>
           </a:ln>
         </p:spPr>
@@ -4603,7 +4603,7 @@
             <a:pPr algn="ctr">
               <a:defRPr sz="1300" b="1">
                 <a:solidFill>
-                  <a:srgbClr val="FFFFFF"/>
+                  <a:srgbClr val="0F172A"/>
                 </a:solidFill>
                 <a:latin typeface="Arial"/>
               </a:defRPr>
@@ -4619,7 +4619,7 @@
               </a:spcBef>
               <a:defRPr sz="1050">
                 <a:solidFill>
-                  <a:srgbClr val="CBD5E1"/>
+                  <a:srgbClr val="475569"/>
                 </a:solidFill>
                 <a:latin typeface="Arial"/>
               </a:defRPr>
@@ -4645,11 +4645,11 @@
             <a:avLst/>
           </a:prstGeom>
           <a:solidFill>
-            <a:srgbClr val="131B2E"/>
+            <a:srgbClr val="FFFFFF"/>
           </a:solidFill>
           <a:ln w="19050">
             <a:solidFill>
-              <a:srgbClr val="EF4444"/>
+              <a:srgbClr val="DC2626"/>
             </a:solidFill>
           </a:ln>
         </p:spPr>
@@ -4674,7 +4674,7 @@
             <a:pPr algn="ctr">
               <a:defRPr sz="1300" b="1">
                 <a:solidFill>
-                  <a:srgbClr val="FFFFFF"/>
+                  <a:srgbClr val="0F172A"/>
                 </a:solidFill>
                 <a:latin typeface="Arial"/>
               </a:defRPr>
@@ -4690,7 +4690,7 @@
               </a:spcBef>
               <a:defRPr sz="1050">
                 <a:solidFill>
-                  <a:srgbClr val="CBD5E1"/>
+                  <a:srgbClr val="475569"/>
                 </a:solidFill>
                 <a:latin typeface="Arial"/>
               </a:defRPr>
@@ -4716,11 +4716,11 @@
             <a:avLst/>
           </a:prstGeom>
           <a:solidFill>
-            <a:srgbClr val="131B2E"/>
+            <a:srgbClr val="FFFFFF"/>
           </a:solidFill>
           <a:ln w="19050">
             <a:solidFill>
-              <a:srgbClr val="06B6D4"/>
+              <a:srgbClr val="0284C7"/>
             </a:solidFill>
           </a:ln>
         </p:spPr>
@@ -4745,7 +4745,7 @@
             <a:pPr algn="ctr">
               <a:defRPr sz="1300" b="1">
                 <a:solidFill>
-                  <a:srgbClr val="FFFFFF"/>
+                  <a:srgbClr val="0F172A"/>
                 </a:solidFill>
                 <a:latin typeface="Arial"/>
               </a:defRPr>
@@ -4761,7 +4761,7 @@
               </a:spcBef>
               <a:defRPr sz="1050">
                 <a:solidFill>
-                  <a:srgbClr val="CBD5E1"/>
+                  <a:srgbClr val="475569"/>
                 </a:solidFill>
                 <a:latin typeface="Arial"/>
               </a:defRPr>
@@ -4829,7 +4829,7 @@
             <a:avLst/>
           </a:prstGeom>
           <a:solidFill>
-            <a:srgbClr val="0A0F1D"/>
+            <a:srgbClr val="F8FAFC"/>
           </a:solidFill>
           <a:ln>
             <a:noFill/>
@@ -4882,7 +4882,7 @@
             <a:pPr>
               <a:defRPr sz="1100" b="1">
                 <a:solidFill>
-                  <a:srgbClr val="06B6D4"/>
+                  <a:srgbClr val="0284C7"/>
                 </a:solidFill>
                 <a:latin typeface="Arial"/>
               </a:defRPr>
@@ -4918,7 +4918,7 @@
             <a:pPr>
               <a:defRPr sz="2600" b="1">
                 <a:solidFill>
-                  <a:srgbClr val="FFFFFF"/>
+                  <a:srgbClr val="0F172A"/>
                 </a:solidFill>
                 <a:latin typeface="Arial"/>
               </a:defRPr>
@@ -4954,7 +4954,7 @@
             <a:pPr>
               <a:defRPr sz="1200">
                 <a:solidFill>
-                  <a:srgbClr val="94A3B8"/>
+                  <a:srgbClr val="64748B"/>
                 </a:solidFill>
                 <a:latin typeface="Arial"/>
               </a:defRPr>
@@ -4980,11 +4980,11 @@
             <a:avLst/>
           </a:prstGeom>
           <a:solidFill>
-            <a:srgbClr val="131B2E"/>
+            <a:srgbClr val="FFFFFF"/>
           </a:solidFill>
           <a:ln w="19050">
             <a:solidFill>
-              <a:srgbClr val="06B6D4"/>
+              <a:srgbClr val="0284C7"/>
             </a:solidFill>
           </a:ln>
         </p:spPr>
@@ -5009,7 +5009,7 @@
             <a:pPr algn="ctr">
               <a:defRPr sz="1300" b="1">
                 <a:solidFill>
-                  <a:srgbClr val="FFFFFF"/>
+                  <a:srgbClr val="0F172A"/>
                 </a:solidFill>
                 <a:latin typeface="Arial"/>
               </a:defRPr>
@@ -5025,7 +5025,7 @@
               </a:spcBef>
               <a:defRPr sz="1050">
                 <a:solidFill>
-                  <a:srgbClr val="CBD5E1"/>
+                  <a:srgbClr val="475569"/>
                 </a:solidFill>
                 <a:latin typeface="Arial"/>
               </a:defRPr>
@@ -5051,11 +5051,11 @@
             <a:avLst/>
           </a:prstGeom>
           <a:solidFill>
-            <a:srgbClr val="131B2E"/>
+            <a:srgbClr val="FFFFFF"/>
           </a:solidFill>
           <a:ln w="19050">
             <a:solidFill>
-              <a:srgbClr val="6366F1"/>
+              <a:srgbClr val="4F46E5"/>
             </a:solidFill>
           </a:ln>
         </p:spPr>
@@ -5080,7 +5080,7 @@
             <a:pPr algn="ctr">
               <a:defRPr sz="1300" b="1">
                 <a:solidFill>
-                  <a:srgbClr val="FFFFFF"/>
+                  <a:srgbClr val="0F172A"/>
                 </a:solidFill>
                 <a:latin typeface="Arial"/>
               </a:defRPr>
@@ -5096,7 +5096,7 @@
               </a:spcBef>
               <a:defRPr sz="1050">
                 <a:solidFill>
-                  <a:srgbClr val="CBD5E1"/>
+                  <a:srgbClr val="475569"/>
                 </a:solidFill>
                 <a:latin typeface="Arial"/>
               </a:defRPr>
@@ -5122,11 +5122,11 @@
             <a:avLst/>
           </a:prstGeom>
           <a:solidFill>
-            <a:srgbClr val="131B2E"/>
+            <a:srgbClr val="FFFFFF"/>
           </a:solidFill>
           <a:ln w="19050">
             <a:solidFill>
-              <a:srgbClr val="10B981"/>
+              <a:srgbClr val="059669"/>
             </a:solidFill>
           </a:ln>
         </p:spPr>
@@ -5151,7 +5151,7 @@
             <a:pPr algn="ctr">
               <a:defRPr sz="1300" b="1">
                 <a:solidFill>
-                  <a:srgbClr val="FFFFFF"/>
+                  <a:srgbClr val="0F172A"/>
                 </a:solidFill>
                 <a:latin typeface="Arial"/>
               </a:defRPr>
@@ -5167,7 +5167,7 @@
               </a:spcBef>
               <a:defRPr sz="1050">
                 <a:solidFill>
-                  <a:srgbClr val="CBD5E1"/>
+                  <a:srgbClr val="475569"/>
                 </a:solidFill>
                 <a:latin typeface="Arial"/>
               </a:defRPr>
@@ -5235,7 +5235,7 @@
             <a:avLst/>
           </a:prstGeom>
           <a:solidFill>
-            <a:srgbClr val="0A0F1D"/>
+            <a:srgbClr val="F8FAFC"/>
           </a:solidFill>
           <a:ln>
             <a:noFill/>
@@ -5288,7 +5288,7 @@
             <a:pPr>
               <a:defRPr sz="1100" b="1">
                 <a:solidFill>
-                  <a:srgbClr val="8B5CF6"/>
+                  <a:srgbClr val="7C3AED"/>
                 </a:solidFill>
                 <a:latin typeface="Arial"/>
               </a:defRPr>
@@ -5324,7 +5324,7 @@
             <a:pPr>
               <a:defRPr sz="2600" b="1">
                 <a:solidFill>
-                  <a:srgbClr val="FFFFFF"/>
+                  <a:srgbClr val="0F172A"/>
                 </a:solidFill>
                 <a:latin typeface="Arial"/>
               </a:defRPr>
@@ -5360,7 +5360,7 @@
             <a:pPr>
               <a:defRPr sz="1200">
                 <a:solidFill>
-                  <a:srgbClr val="94A3B8"/>
+                  <a:srgbClr val="64748B"/>
                 </a:solidFill>
                 <a:latin typeface="Arial"/>
               </a:defRPr>
@@ -5386,11 +5386,11 @@
             <a:avLst/>
           </a:prstGeom>
           <a:solidFill>
-            <a:srgbClr val="131B2E"/>
+            <a:srgbClr val="FFFFFF"/>
           </a:solidFill>
           <a:ln w="19050">
             <a:solidFill>
-              <a:srgbClr val="6366F1"/>
+              <a:srgbClr val="4F46E5"/>
             </a:solidFill>
           </a:ln>
         </p:spPr>
@@ -5415,7 +5415,7 @@
             <a:pPr algn="ctr">
               <a:defRPr sz="1300" b="1">
                 <a:solidFill>
-                  <a:srgbClr val="FFFFFF"/>
+                  <a:srgbClr val="0F172A"/>
                 </a:solidFill>
                 <a:latin typeface="Arial"/>
               </a:defRPr>
@@ -5431,7 +5431,7 @@
               </a:spcBef>
               <a:defRPr sz="1050">
                 <a:solidFill>
-                  <a:srgbClr val="CBD5E1"/>
+                  <a:srgbClr val="475569"/>
                 </a:solidFill>
                 <a:latin typeface="Arial"/>
               </a:defRPr>
@@ -5457,11 +5457,11 @@
             <a:avLst/>
           </a:prstGeom>
           <a:solidFill>
-            <a:srgbClr val="131B2E"/>
+            <a:srgbClr val="FFFFFF"/>
           </a:solidFill>
           <a:ln w="19050">
             <a:solidFill>
-              <a:srgbClr val="10B981"/>
+              <a:srgbClr val="059669"/>
             </a:solidFill>
           </a:ln>
         </p:spPr>
@@ -5486,7 +5486,7 @@
             <a:pPr algn="ctr">
               <a:defRPr sz="1300" b="1">
                 <a:solidFill>
-                  <a:srgbClr val="FFFFFF"/>
+                  <a:srgbClr val="0F172A"/>
                 </a:solidFill>
                 <a:latin typeface="Arial"/>
               </a:defRPr>
@@ -5502,7 +5502,7 @@
               </a:spcBef>
               <a:defRPr sz="1050">
                 <a:solidFill>
-                  <a:srgbClr val="CBD5E1"/>
+                  <a:srgbClr val="475569"/>
                 </a:solidFill>
                 <a:latin typeface="Arial"/>
               </a:defRPr>
@@ -5528,11 +5528,11 @@
             <a:avLst/>
           </a:prstGeom>
           <a:solidFill>
-            <a:srgbClr val="131B2E"/>
+            <a:srgbClr val="FFFFFF"/>
           </a:solidFill>
           <a:ln w="19050">
             <a:solidFill>
-              <a:srgbClr val="06B6D4"/>
+              <a:srgbClr val="0284C7"/>
             </a:solidFill>
           </a:ln>
         </p:spPr>
@@ -5557,7 +5557,7 @@
             <a:pPr algn="ctr">
               <a:defRPr sz="1300" b="1">
                 <a:solidFill>
-                  <a:srgbClr val="FFFFFF"/>
+                  <a:srgbClr val="0F172A"/>
                 </a:solidFill>
                 <a:latin typeface="Arial"/>
               </a:defRPr>
@@ -5573,7 +5573,7 @@
               </a:spcBef>
               <a:defRPr sz="1050">
                 <a:solidFill>
-                  <a:srgbClr val="CBD5E1"/>
+                  <a:srgbClr val="475569"/>
                 </a:solidFill>
                 <a:latin typeface="Arial"/>
               </a:defRPr>
@@ -5599,11 +5599,11 @@
             <a:avLst/>
           </a:prstGeom>
           <a:solidFill>
-            <a:srgbClr val="131B2E"/>
+            <a:srgbClr val="FFFFFF"/>
           </a:solidFill>
           <a:ln w="19050">
             <a:solidFill>
-              <a:srgbClr val="8B5CF6"/>
+              <a:srgbClr val="7C3AED"/>
             </a:solidFill>
           </a:ln>
         </p:spPr>
@@ -5628,7 +5628,7 @@
             <a:pPr algn="ctr">
               <a:defRPr sz="1300" b="1">
                 <a:solidFill>
-                  <a:srgbClr val="FFFFFF"/>
+                  <a:srgbClr val="0F172A"/>
                 </a:solidFill>
                 <a:latin typeface="Arial"/>
               </a:defRPr>
@@ -5644,7 +5644,7 @@
               </a:spcBef>
               <a:defRPr sz="1050">
                 <a:solidFill>
-                  <a:srgbClr val="CBD5E1"/>
+                  <a:srgbClr val="475569"/>
                 </a:solidFill>
                 <a:latin typeface="Arial"/>
               </a:defRPr>
@@ -5712,7 +5712,7 @@
             <a:avLst/>
           </a:prstGeom>
           <a:solidFill>
-            <a:srgbClr val="0A0F1D"/>
+            <a:srgbClr val="F8FAFC"/>
           </a:solidFill>
           <a:ln>
             <a:noFill/>
@@ -5765,7 +5765,7 @@
             <a:pPr>
               <a:defRPr sz="1100" b="1">
                 <a:solidFill>
-                  <a:srgbClr val="10B981"/>
+                  <a:srgbClr val="059669"/>
                 </a:solidFill>
                 <a:latin typeface="Arial"/>
               </a:defRPr>
@@ -5801,7 +5801,7 @@
             <a:pPr>
               <a:defRPr sz="2600" b="1">
                 <a:solidFill>
-                  <a:srgbClr val="FFFFFF"/>
+                  <a:srgbClr val="0F172A"/>
                 </a:solidFill>
                 <a:latin typeface="Arial"/>
               </a:defRPr>
@@ -5837,7 +5837,7 @@
             <a:pPr>
               <a:defRPr sz="1200">
                 <a:solidFill>
-                  <a:srgbClr val="94A3B8"/>
+                  <a:srgbClr val="64748B"/>
                 </a:solidFill>
                 <a:latin typeface="Arial"/>
               </a:defRPr>
@@ -5863,11 +5863,11 @@
             <a:avLst/>
           </a:prstGeom>
           <a:solidFill>
-            <a:srgbClr val="131B2E"/>
+            <a:srgbClr val="FFFFFF"/>
           </a:solidFill>
           <a:ln w="19050">
             <a:solidFill>
-              <a:srgbClr val="10B981"/>
+              <a:srgbClr val="059669"/>
             </a:solidFill>
           </a:ln>
         </p:spPr>
@@ -5892,7 +5892,7 @@
             <a:pPr algn="ctr">
               <a:defRPr sz="1800" b="1">
                 <a:solidFill>
-                  <a:srgbClr val="10B981"/>
+                  <a:srgbClr val="059669"/>
                 </a:solidFill>
                 <a:latin typeface="Arial"/>
               </a:defRPr>
@@ -5905,7 +5905,7 @@
             <a:pPr>
               <a:defRPr sz="1300" b="1">
                 <a:solidFill>
-                  <a:srgbClr val="FFFFFF"/>
+                  <a:srgbClr val="0F172A"/>
                 </a:solidFill>
                 <a:latin typeface="Arial"/>
               </a:defRPr>
@@ -5921,7 +5921,7 @@
               </a:spcBef>
               <a:defRPr sz="1050">
                 <a:solidFill>
-                  <a:srgbClr val="CBD5E1"/>
+                  <a:srgbClr val="475569"/>
                 </a:solidFill>
                 <a:latin typeface="Arial"/>
               </a:defRPr>
@@ -5947,11 +5947,11 @@
             <a:avLst/>
           </a:prstGeom>
           <a:solidFill>
-            <a:srgbClr val="131B2E"/>
+            <a:srgbClr val="FFFFFF"/>
           </a:solidFill>
           <a:ln w="19050">
             <a:solidFill>
-              <a:srgbClr val="6366F1"/>
+              <a:srgbClr val="4F46E5"/>
             </a:solidFill>
           </a:ln>
         </p:spPr>
@@ -5976,7 +5976,7 @@
             <a:pPr algn="ctr">
               <a:defRPr sz="1800" b="1">
                 <a:solidFill>
-                  <a:srgbClr val="6366F1"/>
+                  <a:srgbClr val="4F46E5"/>
                 </a:solidFill>
                 <a:latin typeface="Arial"/>
               </a:defRPr>
@@ -5989,7 +5989,7 @@
             <a:pPr>
               <a:defRPr sz="1300" b="1">
                 <a:solidFill>
-                  <a:srgbClr val="FFFFFF"/>
+                  <a:srgbClr val="0F172A"/>
                 </a:solidFill>
                 <a:latin typeface="Arial"/>
               </a:defRPr>
@@ -6005,7 +6005,7 @@
               </a:spcBef>
               <a:defRPr sz="1050">
                 <a:solidFill>
-                  <a:srgbClr val="CBD5E1"/>
+                  <a:srgbClr val="475569"/>
                 </a:solidFill>
                 <a:latin typeface="Arial"/>
               </a:defRPr>
@@ -6031,11 +6031,11 @@
             <a:avLst/>
           </a:prstGeom>
           <a:solidFill>
-            <a:srgbClr val="131B2E"/>
+            <a:srgbClr val="FFFFFF"/>
           </a:solidFill>
           <a:ln w="19050">
             <a:solidFill>
-              <a:srgbClr val="06B6D4"/>
+              <a:srgbClr val="0284C7"/>
             </a:solidFill>
           </a:ln>
         </p:spPr>
@@ -6060,7 +6060,7 @@
             <a:pPr algn="ctr">
               <a:defRPr sz="1800" b="1">
                 <a:solidFill>
-                  <a:srgbClr val="06B6D4"/>
+                  <a:srgbClr val="0284C7"/>
                 </a:solidFill>
                 <a:latin typeface="Arial"/>
               </a:defRPr>
@@ -6073,7 +6073,7 @@
             <a:pPr>
               <a:defRPr sz="1300" b="1">
                 <a:solidFill>
-                  <a:srgbClr val="FFFFFF"/>
+                  <a:srgbClr val="0F172A"/>
                 </a:solidFill>
                 <a:latin typeface="Arial"/>
               </a:defRPr>
@@ -6089,7 +6089,7 @@
               </a:spcBef>
               <a:defRPr sz="1050">
                 <a:solidFill>
-                  <a:srgbClr val="CBD5E1"/>
+                  <a:srgbClr val="475569"/>
                 </a:solidFill>
                 <a:latin typeface="Arial"/>
               </a:defRPr>
@@ -6115,11 +6115,11 @@
             <a:avLst/>
           </a:prstGeom>
           <a:solidFill>
-            <a:srgbClr val="131B2E"/>
+            <a:srgbClr val="FFFFFF"/>
           </a:solidFill>
           <a:ln w="19050">
             <a:solidFill>
-              <a:srgbClr val="8B5CF6"/>
+              <a:srgbClr val="7C3AED"/>
             </a:solidFill>
           </a:ln>
         </p:spPr>
@@ -6144,7 +6144,7 @@
             <a:pPr algn="ctr">
               <a:defRPr sz="1800" b="1">
                 <a:solidFill>
-                  <a:srgbClr val="8B5CF6"/>
+                  <a:srgbClr val="7C3AED"/>
                 </a:solidFill>
                 <a:latin typeface="Arial"/>
               </a:defRPr>
@@ -6157,7 +6157,7 @@
             <a:pPr>
               <a:defRPr sz="1300" b="1">
                 <a:solidFill>
-                  <a:srgbClr val="FFFFFF"/>
+                  <a:srgbClr val="0F172A"/>
                 </a:solidFill>
                 <a:latin typeface="Arial"/>
               </a:defRPr>
@@ -6173,7 +6173,7 @@
               </a:spcBef>
               <a:defRPr sz="1050">
                 <a:solidFill>
-                  <a:srgbClr val="CBD5E1"/>
+                  <a:srgbClr val="475569"/>
                 </a:solidFill>
                 <a:latin typeface="Arial"/>
               </a:defRPr>
@@ -6241,7 +6241,7 @@
             <a:avLst/>
           </a:prstGeom>
           <a:solidFill>
-            <a:srgbClr val="0A0F1D"/>
+            <a:srgbClr val="F8FAFC"/>
           </a:solidFill>
           <a:ln>
             <a:noFill/>
@@ -6284,11 +6284,11 @@
             <a:avLst/>
           </a:prstGeom>
           <a:solidFill>
-            <a:srgbClr val="131B2E"/>
+            <a:srgbClr val="FFFFFF"/>
           </a:solidFill>
           <a:ln w="25400">
             <a:solidFill>
-              <a:srgbClr val="6366F1"/>
+              <a:srgbClr val="4F46E5"/>
             </a:solidFill>
           </a:ln>
         </p:spPr>
@@ -6313,7 +6313,7 @@
             <a:pPr algn="ctr">
               <a:defRPr sz="1300" b="1">
                 <a:solidFill>
-                  <a:srgbClr val="06B6D4"/>
+                  <a:srgbClr val="0284C7"/>
                 </a:solidFill>
                 <a:latin typeface="Arial"/>
               </a:defRPr>
@@ -6329,7 +6329,7 @@
               </a:spcBef>
               <a:defRPr sz="4600" b="1">
                 <a:solidFill>
-                  <a:srgbClr val="FFFFFF"/>
+                  <a:srgbClr val="0F172A"/>
                 </a:solidFill>
                 <a:latin typeface="Arial"/>
               </a:defRPr>
@@ -6345,7 +6345,7 @@
               </a:spcBef>
               <a:defRPr sz="2000">
                 <a:solidFill>
-                  <a:srgbClr val="6366F1"/>
+                  <a:srgbClr val="4F46E5"/>
                 </a:solidFill>
                 <a:latin typeface="Arial"/>
               </a:defRPr>
@@ -6361,7 +6361,7 @@
               </a:spcBef>
               <a:defRPr sz="1400" b="1">
                 <a:solidFill>
-                  <a:srgbClr val="CBD5E1"/>
+                  <a:srgbClr val="0F172A"/>
                 </a:solidFill>
                 <a:latin typeface="Arial"/>
               </a:defRPr>
@@ -6381,7 +6381,7 @@
               </a:spcBef>
               <a:defRPr sz="1200">
                 <a:solidFill>
-                  <a:srgbClr val="10B981"/>
+                  <a:srgbClr val="059669"/>
                 </a:solidFill>
                 <a:latin typeface="Arial"/>
               </a:defRPr>

</xml_diff>

<commit_message>
Integrate UPI mayurpandav128@okhdfcbank and live payment scanner QR across app and presentations
</commit_message>
<xml_diff>
--- a/public/Vyapar_2.0_Official_Presentation.pptx
+++ b/public/Vyapar_2.0_Official_Presentation.pptx
@@ -6277,8 +6277,8 @@
         </p:nvSpPr>
         <p:spPr>
           <a:xfrm>
-            <a:off x="1097280" y="914400"/>
-            <a:ext cx="9966960" cy="5029200"/>
+            <a:off x="731520" y="731520"/>
+            <a:ext cx="6858000" cy="5394960"/>
           </a:xfrm>
           <a:prstGeom prst="roundRect">
             <a:avLst/>
@@ -6286,7 +6286,7 @@
           <a:solidFill>
             <a:srgbClr val="FFFFFF"/>
           </a:solidFill>
-          <a:ln w="25400">
+          <a:ln w="19050">
             <a:solidFill>
               <a:srgbClr val="4F46E5"/>
             </a:solidFill>
@@ -6307,11 +6307,11 @@
           </a:fontRef>
         </p:style>
         <p:txBody>
-          <a:bodyPr rtlCol="0" anchor="ctr" wrap="square" lIns="548640" rIns="548640" tIns="365760"/>
+          <a:bodyPr rtlCol="0" anchor="ctr" wrap="square" lIns="457200" rIns="457200" tIns="365760"/>
           <a:lstStyle/>
           <a:p>
             <a:pPr algn="ctr">
-              <a:defRPr sz="1300" b="1">
+              <a:defRPr sz="1200" b="1">
                 <a:solidFill>
                   <a:srgbClr val="0284C7"/>
                 </a:solidFill>
@@ -6323,27 +6323,27 @@
             </a:r>
           </a:p>
           <a:p>
-            <a:pPr algn="ctr">
-              <a:spcBef>
-                <a:spcPts val="800"/>
-              </a:spcBef>
-              <a:defRPr sz="4600" b="1">
-                <a:solidFill>
-                  <a:srgbClr val="0F172A"/>
-                </a:solidFill>
-                <a:latin typeface="Arial"/>
-              </a:defRPr>
-            </a:pPr>
-            <a:r>
-              <a:t>Thank You!</a:t>
-            </a:r>
-          </a:p>
-          <a:p>
-            <a:pPr algn="ctr">
+            <a:pPr>
               <a:spcBef>
                 <a:spcPts val="600"/>
               </a:spcBef>
-              <a:defRPr sz="2000">
+              <a:defRPr sz="4400" b="1">
+                <a:solidFill>
+                  <a:srgbClr val="0F172A"/>
+                </a:solidFill>
+                <a:latin typeface="Arial"/>
+              </a:defRPr>
+            </a:pPr>
+            <a:r>
+              <a:t>Thank You!</a:t>
+            </a:r>
+          </a:p>
+          <a:p>
+            <a:pPr>
+              <a:spcBef>
+                <a:spcPts val="400"/>
+              </a:spcBef>
+              <a:defRPr sz="1800">
                 <a:solidFill>
                   <a:srgbClr val="4F46E5"/>
                 </a:solidFill>
@@ -6352,14 +6352,177 @@
             </a:pPr>
             <a:r>
               <a:t>Questions &amp; Live Demonstration</a:t>
+            </a:r>
+          </a:p>
+          <a:p>
+            <a:pPr>
+              <a:spcBef>
+                <a:spcPts val="1600"/>
+              </a:spcBef>
+              <a:defRPr sz="1300" b="1">
+                <a:solidFill>
+                  <a:srgbClr val="0F172A"/>
+                </a:solidFill>
+                <a:latin typeface="Arial"/>
+              </a:defRPr>
+            </a:pPr>
+            <a:r>
+              <a:t>Project Team:</a:t>
+            </a:r>
+            <a:br/>
+            <a:r>
+              <a:t>01 - Pranali Bhagat   |   06 - Hrutuja Champanerkar</a:t>
+            </a:r>
+            <a:br/>
+            <a:r>
+              <a:t>31 - Mayur Pandav   |   37 - Mol Patil</a:t>
+            </a:r>
+          </a:p>
+          <a:p>
+            <a:pPr>
+              <a:spcBef>
+                <a:spcPts val="1400"/>
+              </a:spcBef>
+              <a:defRPr sz="1150">
+                <a:solidFill>
+                  <a:srgbClr val="059669"/>
+                </a:solidFill>
+                <a:latin typeface="Arial"/>
+              </a:defRPr>
+            </a:pPr>
+            <a:r>
+              <a:t>• Live App: http://localhost:5173</a:t>
+            </a:r>
+            <a:br/>
+            <a:r>
+              <a:t>• Live GPS Tracking: http://localhost:5173/track/ORD-TRACK-748490</a:t>
+            </a:r>
+            <a:br/>
+            <a:r>
+              <a:t>• Merchant UPI ID: mayurpandav128@okhdfcbank</a:t>
+            </a:r>
+          </a:p>
+        </p:txBody>
+      </p:sp>
+      <p:sp>
+        <p:nvSpPr>
+          <p:cNvPr id="4" name="Rounded Rectangle 3"/>
+          <p:cNvSpPr/>
+          <p:nvPr/>
+        </p:nvSpPr>
+        <p:spPr>
+          <a:xfrm>
+            <a:off x="7863840" y="731520"/>
+            <a:ext cx="3566160" cy="5394960"/>
+          </a:xfrm>
+          <a:prstGeom prst="roundRect">
+            <a:avLst/>
+          </a:prstGeom>
+          <a:solidFill>
+            <a:srgbClr val="FFFFFF"/>
+          </a:solidFill>
+          <a:ln w="19050">
+            <a:solidFill>
+              <a:srgbClr val="059669"/>
+            </a:solidFill>
+          </a:ln>
+        </p:spPr>
+        <p:style>
+          <a:lnRef idx="1">
+            <a:schemeClr val="accent1"/>
+          </a:lnRef>
+          <a:fillRef idx="3">
+            <a:schemeClr val="accent1"/>
+          </a:fillRef>
+          <a:effectRef idx="2">
+            <a:schemeClr val="accent1"/>
+          </a:effectRef>
+          <a:fontRef idx="minor">
+            <a:schemeClr val="lt1"/>
+          </a:fontRef>
+        </p:style>
+        <p:txBody>
+          <a:bodyPr rtlCol="0" anchor="ctr" wrap="square" lIns="274320" rIns="274320" tIns="320040"/>
+          <a:lstStyle/>
+          <a:p>
+            <a:pPr algn="ctr">
+              <a:defRPr sz="1200" b="1">
+                <a:solidFill>
+                  <a:srgbClr val="059669"/>
+                </a:solidFill>
+                <a:latin typeface="Arial"/>
+              </a:defRPr>
+            </a:pPr>
+            <a:r>
+              <a:t>📲 LIVE UPI SCANNER</a:t>
             </a:r>
           </a:p>
           <a:p>
             <a:pPr algn="ctr">
               <a:spcBef>
-                <a:spcPts val="2200"/>
+                <a:spcPts val="200"/>
               </a:spcBef>
-              <a:defRPr sz="1400" b="1">
+              <a:defRPr sz="1000">
+                <a:solidFill>
+                  <a:srgbClr val="475569"/>
+                </a:solidFill>
+                <a:latin typeface="Arial"/>
+              </a:defRPr>
+            </a:pPr>
+            <a:r>
+              <a:t>Scan to Test Real Settlement</a:t>
+            </a:r>
+          </a:p>
+        </p:txBody>
+      </p:sp>
+      <p:pic>
+        <p:nvPicPr>
+          <p:cNvPr id="5" name="Picture 4" descr="upi_qr.png"/>
+          <p:cNvPicPr>
+            <a:picLocks noChangeAspect="1"/>
+          </p:cNvPicPr>
+          <p:nvPr/>
+        </p:nvPicPr>
+        <p:blipFill>
+          <a:blip r:embed="rId2"/>
+          <a:stretch>
+            <a:fillRect/>
+          </a:stretch>
+        </p:blipFill>
+        <p:spPr>
+          <a:xfrm>
+            <a:off x="8321040" y="1508760"/>
+            <a:ext cx="2651760" cy="3022504"/>
+          </a:xfrm>
+          <a:prstGeom prst="rect">
+            <a:avLst/>
+          </a:prstGeom>
+        </p:spPr>
+      </p:pic>
+      <p:sp>
+        <p:nvSpPr>
+          <p:cNvPr id="6" name="TextBox 5"/>
+          <p:cNvSpPr txBox="1"/>
+          <p:nvPr/>
+        </p:nvSpPr>
+        <p:spPr>
+          <a:xfrm>
+            <a:off x="7955279" y="4572000"/>
+            <a:ext cx="3383280" cy="1371600"/>
+          </a:xfrm>
+          <a:prstGeom prst="rect">
+            <a:avLst/>
+          </a:prstGeom>
+          <a:noFill/>
+        </p:spPr>
+        <p:txBody>
+          <a:bodyPr wrap="square">
+            <a:spAutoFit/>
+          </a:bodyPr>
+          <a:lstStyle/>
+          <a:p>
+            <a:pPr algn="ctr">
+              <a:defRPr sz="1050" b="1">
                 <a:solidFill>
                   <a:srgbClr val="0F172A"/>
                 </a:solidFill>
@@ -6367,27 +6530,23 @@
               </a:defRPr>
             </a:pPr>
             <a:r>
-              <a:t>Project Team:</a:t>
-            </a:r>
-            <a:br/>
-            <a:r>
-              <a:t>01 - Pranali Bhagat   |   06 - Hrutuja Champanerkar   |   31 - Mayur Pandav   |   37 - Mol Patil</a:t>
+              <a:t>UPI ID: mayurpandav128@okhdfcbank</a:t>
             </a:r>
           </a:p>
           <a:p>
             <a:pPr algn="ctr">
               <a:spcBef>
-                <a:spcPts val="1800"/>
+                <a:spcPts val="300"/>
               </a:spcBef>
-              <a:defRPr sz="1200">
-                <a:solidFill>
-                  <a:srgbClr val="059669"/>
-                </a:solidFill>
-                <a:latin typeface="Arial"/>
-              </a:defRPr>
-            </a:pPr>
-            <a:r>
-              <a:t>Live App: http://localhost:5173  •  Live GPS Portal: http://localhost:5173/track/ORD-TRACK-748490</a:t>
+              <a:defRPr sz="950" b="1">
+                <a:solidFill>
+                  <a:srgbClr val="4F46E5"/>
+                </a:solidFill>
+                <a:latin typeface="Arial"/>
+              </a:defRPr>
+            </a:pPr>
+            <a:r>
+              <a:t>⚡ Google Pay • PhonePe • Paytm • BHIM</a:t>
             </a:r>
           </a:p>
         </p:txBody>

</xml_diff>